<commit_message>
Update About page and credits
</commit_message>
<xml_diff>
--- a/downloads/slides/Lesson1_Slides.pptx
+++ b/downloads/slides/Lesson1_Slides.pptx
@@ -1413,13 +1413,13 @@
           <a:p>
             <a:r>
               <a:rPr lang="en-US" dirty="0"/>
-              <a:t>Image credit line copied exactly from images/CREDITS.md. Deck license: CC BY-NC-SA 4.0 (proposed curriculum license, Section 7.4).</a:t>
+              <a:t>Image credit line copied exactly from images/CREDITS.md. Deck notice: © 2026 the authors; the authors license this deck under CC BY-NC-SA 4.0 (Section 7.2).</a:t>
             </a:r>
           </a:p>
           <a:p>
             <a:r>
               <a:rPr lang="en-US" dirty="0"/>
-              <a:t>Independence notice from the curriculum front matter.</a:t>
+              <a:t>Audio and font credits: Chatterbox TTS (Resemble AI, MIT; Perth watermark), Lexend Deca (SIL OFL 1.1).</a:t>
             </a:r>
           </a:p>
         </p:txBody>
@@ -2853,6 +2853,10 @@
           </a:solidFill>
           <a:ln/>
         </p:spPr>
+        <p:txBody>
+          <a:bodyPr/>
+          <a:p/>
+        </p:txBody>
       </p:sp>
       <p:pic>
         <p:nvPicPr>
@@ -2938,6 +2942,10 @@
           </a:solidFill>
           <a:ln/>
         </p:spPr>
+        <p:txBody>
+          <a:bodyPr/>
+          <a:p/>
+        </p:txBody>
       </p:sp>
       <p:sp>
         <p:nvSpPr>
@@ -2960,6 +2968,10 @@
           </a:solidFill>
           <a:ln/>
         </p:spPr>
+        <p:txBody>
+          <a:bodyPr/>
+          <a:p/>
+        </p:txBody>
       </p:sp>
       <p:sp>
         <p:nvSpPr>
@@ -3143,6 +3155,10 @@
           </a:solidFill>
           <a:ln/>
         </p:spPr>
+        <p:txBody>
+          <a:bodyPr/>
+          <a:p/>
+        </p:txBody>
       </p:sp>
       <p:sp>
         <p:nvSpPr>
@@ -3163,6 +3179,10 @@
           </a:solidFill>
           <a:ln/>
         </p:spPr>
+        <p:txBody>
+          <a:bodyPr/>
+          <a:p/>
+        </p:txBody>
       </p:sp>
       <p:sp>
         <p:nvSpPr>
@@ -3183,6 +3203,10 @@
           </a:solidFill>
           <a:ln/>
         </p:spPr>
+        <p:txBody>
+          <a:bodyPr/>
+          <a:p/>
+        </p:txBody>
       </p:sp>
     </p:spTree>
   </p:cSld>
@@ -3242,6 +3266,10 @@
             <a:prstDash val="solid"/>
           </a:ln>
         </p:spPr>
+        <p:txBody>
+          <a:bodyPr/>
+          <a:p/>
+        </p:txBody>
       </p:sp>
       <p:pic>
         <p:nvPicPr>
@@ -3288,6 +3316,10 @@
           </a:solidFill>
           <a:ln/>
         </p:spPr>
+        <p:txBody>
+          <a:bodyPr/>
+          <a:p/>
+        </p:txBody>
       </p:sp>
       <p:sp>
         <p:nvSpPr>
@@ -3310,6 +3342,10 @@
           </a:solidFill>
           <a:ln/>
         </p:spPr>
+        <p:txBody>
+          <a:bodyPr/>
+          <a:p/>
+        </p:txBody>
       </p:sp>
       <p:sp>
         <p:nvSpPr>
@@ -3410,6 +3446,10 @@
             <a:prstDash val="solid"/>
           </a:ln>
         </p:spPr>
+        <p:txBody>
+          <a:bodyPr/>
+          <a:p/>
+        </p:txBody>
       </p:sp>
       <p:sp>
         <p:nvSpPr>
@@ -3430,6 +3470,10 @@
           </a:solidFill>
           <a:ln/>
         </p:spPr>
+        <p:txBody>
+          <a:bodyPr/>
+          <a:p/>
+        </p:txBody>
       </p:sp>
       <p:sp>
         <p:nvSpPr>
@@ -3450,6 +3494,10 @@
           </a:solidFill>
           <a:ln/>
         </p:spPr>
+        <p:txBody>
+          <a:bodyPr/>
+          <a:p/>
+        </p:txBody>
       </p:sp>
       <p:sp>
         <p:nvSpPr>
@@ -3470,6 +3518,10 @@
           </a:solidFill>
           <a:ln/>
         </p:spPr>
+        <p:txBody>
+          <a:bodyPr/>
+          <a:p/>
+        </p:txBody>
       </p:sp>
       <p:sp>
         <p:nvSpPr>
@@ -4382,6 +4434,10 @@
           </a:solidFill>
           <a:ln/>
         </p:spPr>
+        <p:txBody>
+          <a:bodyPr/>
+          <a:p/>
+        </p:txBody>
       </p:sp>
       <p:sp>
         <p:nvSpPr>
@@ -4404,6 +4460,10 @@
           </a:solidFill>
           <a:ln/>
         </p:spPr>
+        <p:txBody>
+          <a:bodyPr/>
+          <a:p/>
+        </p:txBody>
       </p:sp>
       <p:sp>
         <p:nvSpPr>
@@ -4426,6 +4486,10 @@
           </a:solidFill>
           <a:ln/>
         </p:spPr>
+        <p:txBody>
+          <a:bodyPr/>
+          <a:p/>
+        </p:txBody>
       </p:sp>
       <p:sp>
         <p:nvSpPr>
@@ -4448,6 +4512,10 @@
           </a:solidFill>
           <a:ln/>
         </p:spPr>
+        <p:txBody>
+          <a:bodyPr/>
+          <a:p/>
+        </p:txBody>
       </p:sp>
       <p:sp>
         <p:nvSpPr>
@@ -4470,6 +4538,10 @@
           </a:solidFill>
           <a:ln/>
         </p:spPr>
+        <p:txBody>
+          <a:bodyPr/>
+          <a:p/>
+        </p:txBody>
       </p:sp>
       <p:sp>
         <p:nvSpPr>
@@ -4727,6 +4799,10 @@
             <a:prstDash val="solid"/>
           </a:ln>
         </p:spPr>
+        <p:txBody>
+          <a:bodyPr/>
+          <a:p/>
+        </p:txBody>
       </p:sp>
       <p:sp>
         <p:nvSpPr>
@@ -4750,6 +4826,10 @@
             <a:prstDash val="solid"/>
           </a:ln>
         </p:spPr>
+        <p:txBody>
+          <a:bodyPr/>
+          <a:p/>
+        </p:txBody>
       </p:sp>
       <p:pic>
         <p:nvPicPr>
@@ -6014,6 +6094,10 @@
             <a:prstDash val="solid"/>
           </a:ln>
         </p:spPr>
+        <p:txBody>
+          <a:bodyPr/>
+          <a:p/>
+        </p:txBody>
       </p:sp>
       <p:sp>
         <p:nvSpPr>
@@ -6034,6 +6118,10 @@
           </a:solidFill>
           <a:ln/>
         </p:spPr>
+        <p:txBody>
+          <a:bodyPr/>
+          <a:p/>
+        </p:txBody>
       </p:sp>
       <p:sp>
         <p:nvSpPr>
@@ -6056,6 +6144,10 @@
           </a:solidFill>
           <a:ln/>
         </p:spPr>
+        <p:txBody>
+          <a:bodyPr/>
+          <a:p/>
+        </p:txBody>
       </p:sp>
       <p:sp>
         <p:nvSpPr>
@@ -6078,6 +6170,10 @@
           </a:solidFill>
           <a:ln/>
         </p:spPr>
+        <p:txBody>
+          <a:bodyPr/>
+          <a:p/>
+        </p:txBody>
       </p:sp>
       <p:sp>
         <p:nvSpPr>
@@ -6100,6 +6196,10 @@
           </a:solidFill>
           <a:ln/>
         </p:spPr>
+        <p:txBody>
+          <a:bodyPr/>
+          <a:p/>
+        </p:txBody>
       </p:sp>
       <p:sp>
         <p:nvSpPr>
@@ -6122,6 +6222,10 @@
           </a:solidFill>
           <a:ln/>
         </p:spPr>
+        <p:txBody>
+          <a:bodyPr/>
+          <a:p/>
+        </p:txBody>
       </p:sp>
       <p:sp>
         <p:nvSpPr>
@@ -6144,6 +6248,10 @@
           </a:solidFill>
           <a:ln/>
         </p:spPr>
+        <p:txBody>
+          <a:bodyPr/>
+          <a:p/>
+        </p:txBody>
       </p:sp>
       <p:sp>
         <p:nvSpPr>
@@ -6166,6 +6274,10 @@
           </a:solidFill>
           <a:ln/>
         </p:spPr>
+        <p:txBody>
+          <a:bodyPr/>
+          <a:p/>
+        </p:txBody>
       </p:sp>
       <p:sp>
         <p:nvSpPr>
@@ -6225,6 +6337,10 @@
           </a:solidFill>
           <a:ln/>
         </p:spPr>
+        <p:txBody>
+          <a:bodyPr/>
+          <a:p/>
+        </p:txBody>
       </p:sp>
       <p:sp>
         <p:nvSpPr>
@@ -6245,6 +6361,10 @@
           </a:solidFill>
           <a:ln/>
         </p:spPr>
+        <p:txBody>
+          <a:bodyPr/>
+          <a:p/>
+        </p:txBody>
       </p:sp>
       <p:sp>
         <p:nvSpPr>
@@ -6265,6 +6385,10 @@
           </a:solidFill>
           <a:ln/>
         </p:spPr>
+        <p:txBody>
+          <a:bodyPr/>
+          <a:p/>
+        </p:txBody>
       </p:sp>
       <p:pic>
         <p:nvPicPr>
@@ -6936,6 +7060,10 @@
             <a:prstDash val="solid"/>
           </a:ln>
         </p:spPr>
+        <p:txBody>
+          <a:bodyPr/>
+          <a:p/>
+        </p:txBody>
       </p:sp>
       <p:sp>
         <p:nvSpPr>
@@ -6956,6 +7084,10 @@
           </a:solidFill>
           <a:ln/>
         </p:spPr>
+        <p:txBody>
+          <a:bodyPr/>
+          <a:p/>
+        </p:txBody>
       </p:sp>
       <p:sp>
         <p:nvSpPr>
@@ -6978,6 +7110,10 @@
           </a:solidFill>
           <a:ln/>
         </p:spPr>
+        <p:txBody>
+          <a:bodyPr/>
+          <a:p/>
+        </p:txBody>
       </p:sp>
       <p:sp>
         <p:nvSpPr>
@@ -7000,6 +7136,10 @@
           </a:solidFill>
           <a:ln/>
         </p:spPr>
+        <p:txBody>
+          <a:bodyPr/>
+          <a:p/>
+        </p:txBody>
       </p:sp>
       <p:sp>
         <p:nvSpPr>
@@ -7022,6 +7162,10 @@
           </a:solidFill>
           <a:ln/>
         </p:spPr>
+        <p:txBody>
+          <a:bodyPr/>
+          <a:p/>
+        </p:txBody>
       </p:sp>
       <p:sp>
         <p:nvSpPr>
@@ -7044,6 +7188,10 @@
           </a:solidFill>
           <a:ln/>
         </p:spPr>
+        <p:txBody>
+          <a:bodyPr/>
+          <a:p/>
+        </p:txBody>
       </p:sp>
       <p:sp>
         <p:nvSpPr>
@@ -7066,6 +7214,10 @@
           </a:solidFill>
           <a:ln/>
         </p:spPr>
+        <p:txBody>
+          <a:bodyPr/>
+          <a:p/>
+        </p:txBody>
       </p:sp>
       <p:sp>
         <p:nvSpPr>
@@ -7088,6 +7240,10 @@
           </a:solidFill>
           <a:ln/>
         </p:spPr>
+        <p:txBody>
+          <a:bodyPr/>
+          <a:p/>
+        </p:txBody>
       </p:sp>
       <p:sp>
         <p:nvSpPr>
@@ -7147,6 +7303,10 @@
           </a:solidFill>
           <a:ln/>
         </p:spPr>
+        <p:txBody>
+          <a:bodyPr/>
+          <a:p/>
+        </p:txBody>
       </p:sp>
       <p:sp>
         <p:nvSpPr>
@@ -7167,6 +7327,10 @@
           </a:solidFill>
           <a:ln/>
         </p:spPr>
+        <p:txBody>
+          <a:bodyPr/>
+          <a:p/>
+        </p:txBody>
       </p:sp>
       <p:sp>
         <p:nvSpPr>
@@ -7187,6 +7351,10 @@
           </a:solidFill>
           <a:ln/>
         </p:spPr>
+        <p:txBody>
+          <a:bodyPr/>
+          <a:p/>
+        </p:txBody>
       </p:sp>
       <p:pic>
         <p:nvPicPr>
@@ -7931,6 +8099,10 @@
           </a:solidFill>
           <a:ln/>
         </p:spPr>
+        <p:txBody>
+          <a:bodyPr/>
+          <a:p/>
+        </p:txBody>
       </p:sp>
       <p:sp>
         <p:nvSpPr>
@@ -7958,6 +8130,10 @@
             <a:prstDash val="solid"/>
           </a:ln>
         </p:spPr>
+        <p:txBody>
+          <a:bodyPr/>
+          <a:p/>
+        </p:txBody>
       </p:sp>
       <p:sp>
         <p:nvSpPr>
@@ -7978,6 +8154,10 @@
           </a:solidFill>
           <a:ln/>
         </p:spPr>
+        <p:txBody>
+          <a:bodyPr/>
+          <a:p/>
+        </p:txBody>
       </p:sp>
       <p:sp>
         <p:nvSpPr>
@@ -8078,6 +8258,10 @@
           </a:solidFill>
           <a:ln/>
         </p:spPr>
+        <p:txBody>
+          <a:bodyPr/>
+          <a:p/>
+        </p:txBody>
       </p:sp>
       <p:sp>
         <p:nvSpPr>
@@ -8105,6 +8289,10 @@
             <a:prstDash val="solid"/>
           </a:ln>
         </p:spPr>
+        <p:txBody>
+          <a:bodyPr/>
+          <a:p/>
+        </p:txBody>
       </p:sp>
       <p:sp>
         <p:nvSpPr>
@@ -8125,6 +8313,10 @@
           </a:solidFill>
           <a:ln/>
         </p:spPr>
+        <p:txBody>
+          <a:bodyPr/>
+          <a:p/>
+        </p:txBody>
       </p:sp>
       <p:sp>
         <p:nvSpPr>
@@ -8225,6 +8417,10 @@
           </a:solidFill>
           <a:ln/>
         </p:spPr>
+        <p:txBody>
+          <a:bodyPr/>
+          <a:p/>
+        </p:txBody>
       </p:sp>
       <p:sp>
         <p:nvSpPr>
@@ -8252,6 +8448,10 @@
             <a:prstDash val="solid"/>
           </a:ln>
         </p:spPr>
+        <p:txBody>
+          <a:bodyPr/>
+          <a:p/>
+        </p:txBody>
       </p:sp>
       <p:sp>
         <p:nvSpPr>
@@ -8272,6 +8472,10 @@
           </a:solidFill>
           <a:ln/>
         </p:spPr>
+        <p:txBody>
+          <a:bodyPr/>
+          <a:p/>
+        </p:txBody>
       </p:sp>
       <p:sp>
         <p:nvSpPr>
@@ -8370,6 +8574,10 @@
           </a:solidFill>
           <a:ln/>
         </p:spPr>
+        <p:txBody>
+          <a:bodyPr/>
+          <a:p/>
+        </p:txBody>
       </p:sp>
       <p:sp>
         <p:nvSpPr>
@@ -8390,6 +8598,10 @@
           </a:solidFill>
           <a:ln/>
         </p:spPr>
+        <p:txBody>
+          <a:bodyPr/>
+          <a:p/>
+        </p:txBody>
       </p:sp>
       <p:sp>
         <p:nvSpPr>
@@ -8410,6 +8622,10 @@
           </a:solidFill>
           <a:ln/>
         </p:spPr>
+        <p:txBody>
+          <a:bodyPr/>
+          <a:p/>
+        </p:txBody>
       </p:sp>
       <p:sp>
         <p:nvSpPr>
@@ -8792,6 +9008,10 @@
           </a:solidFill>
           <a:ln/>
         </p:spPr>
+        <p:txBody>
+          <a:bodyPr/>
+          <a:p/>
+        </p:txBody>
       </p:sp>
       <p:pic>
         <p:nvPicPr>
@@ -8838,6 +9058,10 @@
           </a:solidFill>
           <a:ln/>
         </p:spPr>
+        <p:txBody>
+          <a:bodyPr/>
+          <a:p/>
+        </p:txBody>
       </p:sp>
       <p:sp>
         <p:nvSpPr>
@@ -8860,6 +9084,10 @@
           </a:solidFill>
           <a:ln/>
         </p:spPr>
+        <p:txBody>
+          <a:bodyPr/>
+          <a:p/>
+        </p:txBody>
       </p:sp>
       <p:sp>
         <p:nvSpPr>
@@ -8882,6 +9110,10 @@
           </a:solidFill>
           <a:ln/>
         </p:spPr>
+        <p:txBody>
+          <a:bodyPr/>
+          <a:p/>
+        </p:txBody>
       </p:sp>
       <p:sp>
         <p:nvSpPr>
@@ -8904,6 +9136,10 @@
           </a:solidFill>
           <a:ln/>
         </p:spPr>
+        <p:txBody>
+          <a:bodyPr/>
+          <a:p/>
+        </p:txBody>
       </p:sp>
       <p:sp>
         <p:nvSpPr>
@@ -9581,6 +9817,10 @@
             <a:prstDash val="solid"/>
           </a:ln>
         </p:spPr>
+        <p:txBody>
+          <a:bodyPr/>
+          <a:p/>
+        </p:txBody>
       </p:sp>
       <p:pic>
         <p:nvPicPr>
@@ -9627,6 +9867,10 @@
           </a:solidFill>
           <a:ln/>
         </p:spPr>
+        <p:txBody>
+          <a:bodyPr/>
+          <a:p/>
+        </p:txBody>
       </p:sp>
       <p:sp>
         <p:nvSpPr>
@@ -9649,6 +9893,10 @@
           </a:solidFill>
           <a:ln/>
         </p:spPr>
+        <p:txBody>
+          <a:bodyPr/>
+          <a:p/>
+        </p:txBody>
       </p:sp>
       <p:sp>
         <p:nvSpPr>
@@ -9773,6 +10021,10 @@
             <a:prstDash val="solid"/>
           </a:ln>
         </p:spPr>
+        <p:txBody>
+          <a:bodyPr/>
+          <a:p/>
+        </p:txBody>
       </p:sp>
       <p:sp>
         <p:nvSpPr>
@@ -9796,6 +10048,10 @@
             <a:prstDash val="solid"/>
           </a:ln>
         </p:spPr>
+        <p:txBody>
+          <a:bodyPr/>
+          <a:p/>
+        </p:txBody>
       </p:sp>
       <p:sp>
         <p:nvSpPr>
@@ -9857,6 +10113,10 @@
           </a:solidFill>
           <a:ln/>
         </p:spPr>
+        <p:txBody>
+          <a:bodyPr/>
+          <a:p/>
+        </p:txBody>
       </p:sp>
       <p:sp>
         <p:nvSpPr>
@@ -9879,6 +10139,10 @@
           </a:solidFill>
           <a:ln/>
         </p:spPr>
+        <p:txBody>
+          <a:bodyPr/>
+          <a:p/>
+        </p:txBody>
       </p:sp>
       <p:sp>
         <p:nvSpPr>
@@ -9899,6 +10163,10 @@
           </a:solidFill>
           <a:ln/>
         </p:spPr>
+        <p:txBody>
+          <a:bodyPr/>
+          <a:p/>
+        </p:txBody>
       </p:sp>
       <p:sp>
         <p:nvSpPr>
@@ -9919,6 +10187,10 @@
           </a:solidFill>
           <a:ln/>
         </p:spPr>
+        <p:txBody>
+          <a:bodyPr/>
+          <a:p/>
+        </p:txBody>
       </p:sp>
       <p:sp>
         <p:nvSpPr>
@@ -9939,6 +10211,10 @@
           </a:solidFill>
           <a:ln/>
         </p:spPr>
+        <p:txBody>
+          <a:bodyPr/>
+          <a:p/>
+        </p:txBody>
       </p:sp>
       <p:sp>
         <p:nvSpPr>
@@ -10600,6 +10876,10 @@
           </a:solidFill>
           <a:ln/>
         </p:spPr>
+        <p:txBody>
+          <a:bodyPr/>
+          <a:p/>
+        </p:txBody>
       </p:sp>
       <p:sp>
         <p:nvSpPr>
@@ -10622,6 +10902,10 @@
           </a:solidFill>
           <a:ln/>
         </p:spPr>
+        <p:txBody>
+          <a:bodyPr/>
+          <a:p/>
+        </p:txBody>
       </p:sp>
       <p:sp>
         <p:nvSpPr>
@@ -10644,6 +10928,10 @@
           </a:solidFill>
           <a:ln/>
         </p:spPr>
+        <p:txBody>
+          <a:bodyPr/>
+          <a:p/>
+        </p:txBody>
       </p:sp>
       <p:sp>
         <p:nvSpPr>
@@ -10703,6 +10991,10 @@
           </a:solidFill>
           <a:ln/>
         </p:spPr>
+        <p:txBody>
+          <a:bodyPr/>
+          <a:p/>
+        </p:txBody>
       </p:sp>
       <p:sp>
         <p:nvSpPr>
@@ -10723,6 +11015,10 @@
           </a:solidFill>
           <a:ln/>
         </p:spPr>
+        <p:txBody>
+          <a:bodyPr/>
+          <a:p/>
+        </p:txBody>
       </p:sp>
       <p:sp>
         <p:nvSpPr>
@@ -10743,6 +11039,10 @@
           </a:solidFill>
           <a:ln/>
         </p:spPr>
+        <p:txBody>
+          <a:bodyPr/>
+          <a:p/>
+        </p:txBody>
       </p:sp>
       <p:pic>
         <p:nvPicPr>
@@ -11249,6 +11549,10 @@
           </a:solidFill>
           <a:ln/>
         </p:spPr>
+        <p:txBody>
+          <a:bodyPr/>
+          <a:p/>
+        </p:txBody>
       </p:sp>
       <p:sp>
         <p:nvSpPr>
@@ -11271,6 +11575,10 @@
           </a:solidFill>
           <a:ln/>
         </p:spPr>
+        <p:txBody>
+          <a:bodyPr/>
+          <a:p/>
+        </p:txBody>
       </p:sp>
       <p:sp>
         <p:nvSpPr>
@@ -11293,6 +11601,10 @@
           </a:solidFill>
           <a:ln/>
         </p:spPr>
+        <p:txBody>
+          <a:bodyPr/>
+          <a:p/>
+        </p:txBody>
       </p:sp>
       <p:sp>
         <p:nvSpPr>
@@ -11315,6 +11627,10 @@
           </a:solidFill>
           <a:ln/>
         </p:spPr>
+        <p:txBody>
+          <a:bodyPr/>
+          <a:p/>
+        </p:txBody>
       </p:sp>
       <p:sp>
         <p:nvSpPr>
@@ -11374,6 +11690,10 @@
           </a:solidFill>
           <a:ln/>
         </p:spPr>
+        <p:txBody>
+          <a:bodyPr/>
+          <a:p/>
+        </p:txBody>
       </p:sp>
       <p:sp>
         <p:nvSpPr>
@@ -11394,6 +11714,10 @@
           </a:solidFill>
           <a:ln/>
         </p:spPr>
+        <p:txBody>
+          <a:bodyPr/>
+          <a:p/>
+        </p:txBody>
       </p:sp>
       <p:sp>
         <p:nvSpPr>
@@ -11414,6 +11738,10 @@
           </a:solidFill>
           <a:ln/>
         </p:spPr>
+        <p:txBody>
+          <a:bodyPr/>
+          <a:p/>
+        </p:txBody>
       </p:sp>
       <p:sp>
         <p:nvSpPr>
@@ -11549,7 +11877,7 @@
                 <a:ea typeface="Lexend Deca" pitchFamily="34" charset="-122"/>
                 <a:cs typeface="Lexend Deca" pitchFamily="34" charset="-120"/>
               </a:rPr>
-              <a:t>License: CC BY-NC-SA 4.0</a:t>
+              <a:t>© 2026 the authors. The authors license this deck under CC BY-NC-SA 4.0.</a:t>
             </a:r>
             <a:endParaRPr lang="en-US" sz="2000" dirty="0"/>
           </a:p>
@@ -11557,7 +11885,7 @@
       </p:sp>
       <p:sp>
         <p:nvSpPr>
-          <p:cNvPr id="17" name="Independence"/>
+          <p:cNvPr id="17" name="AudioFontCredits"/>
           <p:cNvSpPr/>
           <p:nvPr/>
         </p:nvSpPr>
@@ -11599,7 +11927,7 @@
                 <a:ea typeface="Lexend Deca" pitchFamily="34" charset="-122"/>
                 <a:cs typeface="Lexend Deca" pitchFamily="34" charset="-120"/>
               </a:rPr>
-              <a:t>About</a:t>
+              <a:t>Audio and font</a:t>
             </a:r>
             <a:endParaRPr lang="en-US" sz="2200" dirty="0"/>
           </a:p>
@@ -11619,7 +11947,7 @@
                 <a:ea typeface="Lexend Deca" pitchFamily="34" charset="-122"/>
                 <a:cs typeface="Lexend Deca" pitchFamily="34" charset="-120"/>
               </a:rPr>
-              <a:t>Independent project, not affiliated with or endorsed by Intercambio Uniting Communities.</a:t>
+              <a:t>Audio: Chatterbox TTS (Resemble AI, MIT); AI voices with a Perth watermark. Font: Lexend Deca (OFL 1.1). Provided as-is, without warranty.</a:t>
             </a:r>
             <a:endParaRPr lang="en-US" sz="2000" dirty="0"/>
           </a:p>
@@ -11678,6 +12006,10 @@
           </a:solidFill>
           <a:ln/>
         </p:spPr>
+        <p:txBody>
+          <a:bodyPr/>
+          <a:p/>
+        </p:txBody>
       </p:sp>
       <p:sp>
         <p:nvSpPr>
@@ -11700,6 +12032,10 @@
           </a:solidFill>
           <a:ln/>
         </p:spPr>
+        <p:txBody>
+          <a:bodyPr/>
+          <a:p/>
+        </p:txBody>
       </p:sp>
       <p:sp>
         <p:nvSpPr>
@@ -11727,6 +12063,10 @@
             <a:prstDash val="solid"/>
           </a:ln>
         </p:spPr>
+        <p:txBody>
+          <a:bodyPr/>
+          <a:p/>
+        </p:txBody>
       </p:sp>
       <p:pic>
         <p:nvPicPr>
@@ -12043,6 +12383,10 @@
           </a:solidFill>
           <a:ln/>
         </p:spPr>
+        <p:txBody>
+          <a:bodyPr/>
+          <a:p/>
+        </p:txBody>
       </p:sp>
       <p:sp>
         <p:nvSpPr>
@@ -12063,6 +12407,10 @@
           </a:solidFill>
           <a:ln/>
         </p:spPr>
+        <p:txBody>
+          <a:bodyPr/>
+          <a:p/>
+        </p:txBody>
       </p:sp>
       <p:sp>
         <p:nvSpPr>
@@ -12083,6 +12431,10 @@
           </a:solidFill>
           <a:ln/>
         </p:spPr>
+        <p:txBody>
+          <a:bodyPr/>
+          <a:p/>
+        </p:txBody>
       </p:sp>
     </p:spTree>
   </p:cSld>
@@ -12273,6 +12625,10 @@
           </a:solidFill>
           <a:ln/>
         </p:spPr>
+        <p:txBody>
+          <a:bodyPr/>
+          <a:p/>
+        </p:txBody>
       </p:sp>
       <p:sp>
         <p:nvSpPr>
@@ -12295,6 +12651,10 @@
           </a:solidFill>
           <a:ln/>
         </p:spPr>
+        <p:txBody>
+          <a:bodyPr/>
+          <a:p/>
+        </p:txBody>
       </p:sp>
       <p:sp>
         <p:nvSpPr>
@@ -12317,6 +12677,10 @@
           </a:solidFill>
           <a:ln/>
         </p:spPr>
+        <p:txBody>
+          <a:bodyPr/>
+          <a:p/>
+        </p:txBody>
       </p:sp>
       <p:sp>
         <p:nvSpPr>
@@ -12339,6 +12703,10 @@
           </a:solidFill>
           <a:ln/>
         </p:spPr>
+        <p:txBody>
+          <a:bodyPr/>
+          <a:p/>
+        </p:txBody>
       </p:sp>
       <p:sp>
         <p:nvSpPr>
@@ -12361,6 +12729,10 @@
           </a:solidFill>
           <a:ln/>
         </p:spPr>
+        <p:txBody>
+          <a:bodyPr/>
+          <a:p/>
+        </p:txBody>
       </p:sp>
       <p:sp>
         <p:nvSpPr>
@@ -12383,6 +12755,10 @@
           </a:solidFill>
           <a:ln/>
         </p:spPr>
+        <p:txBody>
+          <a:bodyPr/>
+          <a:p/>
+        </p:txBody>
       </p:sp>
       <p:sp>
         <p:nvSpPr>
@@ -12481,6 +12857,10 @@
           </a:solidFill>
           <a:ln/>
         </p:spPr>
+        <p:txBody>
+          <a:bodyPr/>
+          <a:p/>
+        </p:txBody>
       </p:sp>
       <p:sp>
         <p:nvSpPr>
@@ -12540,6 +12920,10 @@
           </a:solidFill>
           <a:ln/>
         </p:spPr>
+        <p:txBody>
+          <a:bodyPr/>
+          <a:p/>
+        </p:txBody>
       </p:sp>
       <p:sp>
         <p:nvSpPr>
@@ -12599,6 +12983,10 @@
           </a:solidFill>
           <a:ln/>
         </p:spPr>
+        <p:txBody>
+          <a:bodyPr/>
+          <a:p/>
+        </p:txBody>
       </p:sp>
       <p:sp>
         <p:nvSpPr>
@@ -12658,6 +13046,10 @@
           </a:solidFill>
           <a:ln/>
         </p:spPr>
+        <p:txBody>
+          <a:bodyPr/>
+          <a:p/>
+        </p:txBody>
       </p:sp>
       <p:sp>
         <p:nvSpPr>
@@ -12717,6 +13109,10 @@
           </a:solidFill>
           <a:ln/>
         </p:spPr>
+        <p:txBody>
+          <a:bodyPr/>
+          <a:p/>
+        </p:txBody>
       </p:sp>
       <p:sp>
         <p:nvSpPr>
@@ -12737,6 +13133,10 @@
           </a:solidFill>
           <a:ln/>
         </p:spPr>
+        <p:txBody>
+          <a:bodyPr/>
+          <a:p/>
+        </p:txBody>
       </p:sp>
       <p:sp>
         <p:nvSpPr>
@@ -12796,6 +13196,10 @@
           </a:solidFill>
           <a:ln/>
         </p:spPr>
+        <p:txBody>
+          <a:bodyPr/>
+          <a:p/>
+        </p:txBody>
       </p:sp>
       <p:sp>
         <p:nvSpPr>
@@ -12855,6 +13259,10 @@
           </a:solidFill>
           <a:ln/>
         </p:spPr>
+        <p:txBody>
+          <a:bodyPr/>
+          <a:p/>
+        </p:txBody>
       </p:sp>
       <p:sp>
         <p:nvSpPr>
@@ -12914,6 +13322,10 @@
           </a:solidFill>
           <a:ln/>
         </p:spPr>
+        <p:txBody>
+          <a:bodyPr/>
+          <a:p/>
+        </p:txBody>
       </p:sp>
       <p:sp>
         <p:nvSpPr>
@@ -12973,6 +13385,10 @@
           </a:solidFill>
           <a:ln/>
         </p:spPr>
+        <p:txBody>
+          <a:bodyPr/>
+          <a:p/>
+        </p:txBody>
       </p:sp>
       <p:sp>
         <p:nvSpPr>
@@ -13179,6 +13595,10 @@
           </a:solidFill>
           <a:ln/>
         </p:spPr>
+        <p:txBody>
+          <a:bodyPr/>
+          <a:p/>
+        </p:txBody>
       </p:sp>
       <p:sp>
         <p:nvSpPr>
@@ -13199,6 +13619,10 @@
           </a:solidFill>
           <a:ln/>
         </p:spPr>
+        <p:txBody>
+          <a:bodyPr/>
+          <a:p/>
+        </p:txBody>
       </p:sp>
       <p:sp>
         <p:nvSpPr>
@@ -13219,6 +13643,10 @@
           </a:solidFill>
           <a:ln/>
         </p:spPr>
+        <p:txBody>
+          <a:bodyPr/>
+          <a:p/>
+        </p:txBody>
       </p:sp>
     </p:spTree>
   </p:cSld>
@@ -14338,6 +14766,10 @@
           </a:solidFill>
           <a:ln/>
         </p:spPr>
+        <p:txBody>
+          <a:bodyPr/>
+          <a:p/>
+        </p:txBody>
       </p:sp>
       <p:sp>
         <p:nvSpPr>
@@ -14360,6 +14792,10 @@
           </a:solidFill>
           <a:ln/>
         </p:spPr>
+        <p:txBody>
+          <a:bodyPr/>
+          <a:p/>
+        </p:txBody>
       </p:sp>
       <p:sp>
         <p:nvSpPr>
@@ -14382,6 +14818,10 @@
           </a:solidFill>
           <a:ln/>
         </p:spPr>
+        <p:txBody>
+          <a:bodyPr/>
+          <a:p/>
+        </p:txBody>
       </p:sp>
       <p:sp>
         <p:nvSpPr>
@@ -14404,6 +14844,10 @@
           </a:solidFill>
           <a:ln/>
         </p:spPr>
+        <p:txBody>
+          <a:bodyPr/>
+          <a:p/>
+        </p:txBody>
       </p:sp>
       <p:sp>
         <p:nvSpPr>
@@ -14465,6 +14909,10 @@
           </a:solidFill>
           <a:ln/>
         </p:spPr>
+        <p:txBody>
+          <a:bodyPr/>
+          <a:p/>
+        </p:txBody>
       </p:sp>
       <p:sp>
         <p:nvSpPr>
@@ -14485,6 +14933,10 @@
           </a:solidFill>
           <a:ln/>
         </p:spPr>
+        <p:txBody>
+          <a:bodyPr/>
+          <a:p/>
+        </p:txBody>
       </p:sp>
       <p:sp>
         <p:nvSpPr>
@@ -14505,6 +14957,10 @@
           </a:solidFill>
           <a:ln/>
         </p:spPr>
+        <p:txBody>
+          <a:bodyPr/>
+          <a:p/>
+        </p:txBody>
       </p:sp>
       <p:sp>
         <p:nvSpPr>
@@ -14525,6 +14981,10 @@
           </a:solidFill>
           <a:ln/>
         </p:spPr>
+        <p:txBody>
+          <a:bodyPr/>
+          <a:p/>
+        </p:txBody>
       </p:sp>
       <p:sp>
         <p:nvSpPr>
@@ -15409,6 +15869,10 @@
           </a:solidFill>
           <a:ln/>
         </p:spPr>
+        <p:txBody>
+          <a:bodyPr/>
+          <a:p/>
+        </p:txBody>
       </p:sp>
       <p:sp>
         <p:nvSpPr>
@@ -15431,6 +15895,10 @@
           </a:solidFill>
           <a:ln/>
         </p:spPr>
+        <p:txBody>
+          <a:bodyPr/>
+          <a:p/>
+        </p:txBody>
       </p:sp>
       <p:sp>
         <p:nvSpPr>
@@ -15453,6 +15921,10 @@
           </a:solidFill>
           <a:ln/>
         </p:spPr>
+        <p:txBody>
+          <a:bodyPr/>
+          <a:p/>
+        </p:txBody>
       </p:sp>
       <p:sp>
         <p:nvSpPr>
@@ -15475,6 +15947,10 @@
           </a:solidFill>
           <a:ln/>
         </p:spPr>
+        <p:txBody>
+          <a:bodyPr/>
+          <a:p/>
+        </p:txBody>
       </p:sp>
       <p:sp>
         <p:nvSpPr>
@@ -15536,6 +16012,10 @@
           </a:solidFill>
           <a:ln/>
         </p:spPr>
+        <p:txBody>
+          <a:bodyPr/>
+          <a:p/>
+        </p:txBody>
       </p:sp>
       <p:sp>
         <p:nvSpPr>
@@ -15556,6 +16036,10 @@
           </a:solidFill>
           <a:ln/>
         </p:spPr>
+        <p:txBody>
+          <a:bodyPr/>
+          <a:p/>
+        </p:txBody>
       </p:sp>
       <p:sp>
         <p:nvSpPr>
@@ -15576,6 +16060,10 @@
           </a:solidFill>
           <a:ln/>
         </p:spPr>
+        <p:txBody>
+          <a:bodyPr/>
+          <a:p/>
+        </p:txBody>
       </p:sp>
       <p:sp>
         <p:nvSpPr>
@@ -15596,6 +16084,10 @@
           </a:solidFill>
           <a:ln/>
         </p:spPr>
+        <p:txBody>
+          <a:bodyPr/>
+          <a:p/>
+        </p:txBody>
       </p:sp>
       <p:sp>
         <p:nvSpPr>
@@ -16480,6 +16972,10 @@
           </a:solidFill>
           <a:ln/>
         </p:spPr>
+        <p:txBody>
+          <a:bodyPr/>
+          <a:p/>
+        </p:txBody>
       </p:sp>
       <p:sp>
         <p:nvSpPr>
@@ -16502,6 +16998,10 @@
           </a:solidFill>
           <a:ln/>
         </p:spPr>
+        <p:txBody>
+          <a:bodyPr/>
+          <a:p/>
+        </p:txBody>
       </p:sp>
       <p:sp>
         <p:nvSpPr>
@@ -16524,6 +17024,10 @@
           </a:solidFill>
           <a:ln/>
         </p:spPr>
+        <p:txBody>
+          <a:bodyPr/>
+          <a:p/>
+        </p:txBody>
       </p:sp>
       <p:sp>
         <p:nvSpPr>
@@ -16546,6 +17050,10 @@
           </a:solidFill>
           <a:ln/>
         </p:spPr>
+        <p:txBody>
+          <a:bodyPr/>
+          <a:p/>
+        </p:txBody>
       </p:sp>
       <p:sp>
         <p:nvSpPr>
@@ -16667,6 +17175,10 @@
           </a:solidFill>
           <a:ln/>
         </p:spPr>
+        <p:txBody>
+          <a:bodyPr/>
+          <a:p/>
+        </p:txBody>
       </p:sp>
       <p:sp>
         <p:nvSpPr>
@@ -16687,6 +17199,10 @@
           </a:solidFill>
           <a:ln/>
         </p:spPr>
+        <p:txBody>
+          <a:bodyPr/>
+          <a:p/>
+        </p:txBody>
       </p:sp>
       <p:sp>
         <p:nvSpPr>
@@ -16707,6 +17223,10 @@
           </a:solidFill>
           <a:ln/>
         </p:spPr>
+        <p:txBody>
+          <a:bodyPr/>
+          <a:p/>
+        </p:txBody>
       </p:sp>
       <p:sp>
         <p:nvSpPr>
@@ -18146,6 +18666,10 @@
           </a:solidFill>
           <a:ln/>
         </p:spPr>
+        <p:txBody>
+          <a:bodyPr/>
+          <a:p/>
+        </p:txBody>
       </p:sp>
       <p:sp>
         <p:nvSpPr>
@@ -18168,6 +18692,10 @@
           </a:solidFill>
           <a:ln/>
         </p:spPr>
+        <p:txBody>
+          <a:bodyPr/>
+          <a:p/>
+        </p:txBody>
       </p:sp>
       <p:sp>
         <p:nvSpPr>
@@ -18229,6 +18757,10 @@
           </a:solidFill>
           <a:ln/>
         </p:spPr>
+        <p:txBody>
+          <a:bodyPr/>
+          <a:p/>
+        </p:txBody>
       </p:sp>
       <p:sp>
         <p:nvSpPr>
@@ -18251,6 +18783,10 @@
           </a:solidFill>
           <a:ln/>
         </p:spPr>
+        <p:txBody>
+          <a:bodyPr/>
+          <a:p/>
+        </p:txBody>
       </p:sp>
       <p:sp>
         <p:nvSpPr>
@@ -18273,6 +18809,10 @@
           </a:solidFill>
           <a:ln/>
         </p:spPr>
+        <p:txBody>
+          <a:bodyPr/>
+          <a:p/>
+        </p:txBody>
       </p:sp>
       <p:sp>
         <p:nvSpPr>
@@ -18295,6 +18835,10 @@
           </a:solidFill>
           <a:ln/>
         </p:spPr>
+        <p:txBody>
+          <a:bodyPr/>
+          <a:p/>
+        </p:txBody>
       </p:sp>
       <p:sp>
         <p:nvSpPr>
@@ -18317,6 +18861,10 @@
           </a:solidFill>
           <a:ln/>
         </p:spPr>
+        <p:txBody>
+          <a:bodyPr/>
+          <a:p/>
+        </p:txBody>
       </p:sp>
       <p:sp>
         <p:nvSpPr>
@@ -18417,6 +18965,10 @@
           </a:solidFill>
           <a:ln/>
         </p:spPr>
+        <p:txBody>
+          <a:bodyPr/>
+          <a:p/>
+        </p:txBody>
       </p:sp>
       <p:sp>
         <p:nvSpPr>
@@ -18439,6 +18991,10 @@
           </a:solidFill>
           <a:ln/>
         </p:spPr>
+        <p:txBody>
+          <a:bodyPr/>
+          <a:p/>
+        </p:txBody>
       </p:sp>
       <p:sp>
         <p:nvSpPr>
@@ -18539,6 +19095,10 @@
           </a:solidFill>
           <a:ln/>
         </p:spPr>
+        <p:txBody>
+          <a:bodyPr/>
+          <a:p/>
+        </p:txBody>
       </p:sp>
       <p:sp>
         <p:nvSpPr>
@@ -18561,6 +19121,10 @@
           </a:solidFill>
           <a:ln/>
         </p:spPr>
+        <p:txBody>
+          <a:bodyPr/>
+          <a:p/>
+        </p:txBody>
       </p:sp>
       <p:sp>
         <p:nvSpPr>
@@ -18659,6 +19223,10 @@
           </a:solidFill>
           <a:ln/>
         </p:spPr>
+        <p:txBody>
+          <a:bodyPr/>
+          <a:p/>
+        </p:txBody>
       </p:sp>
       <p:sp>
         <p:nvSpPr>
@@ -18679,6 +19247,10 @@
           </a:solidFill>
           <a:ln/>
         </p:spPr>
+        <p:txBody>
+          <a:bodyPr/>
+          <a:p/>
+        </p:txBody>
       </p:sp>
       <p:sp>
         <p:nvSpPr>
@@ -18699,6 +19271,10 @@
           </a:solidFill>
           <a:ln/>
         </p:spPr>
+        <p:txBody>
+          <a:bodyPr/>
+          <a:p/>
+        </p:txBody>
       </p:sp>
       <p:sp>
         <p:nvSpPr>
@@ -19543,6 +20119,10 @@
           </a:solidFill>
           <a:ln/>
         </p:spPr>
+        <p:txBody>
+          <a:bodyPr/>
+          <a:p/>
+        </p:txBody>
       </p:sp>
       <p:sp>
         <p:nvSpPr>
@@ -19565,6 +20145,10 @@
           </a:solidFill>
           <a:ln/>
         </p:spPr>
+        <p:txBody>
+          <a:bodyPr/>
+          <a:p/>
+        </p:txBody>
       </p:sp>
       <p:sp>
         <p:nvSpPr>
@@ -19587,6 +20171,10 @@
           </a:solidFill>
           <a:ln/>
         </p:spPr>
+        <p:txBody>
+          <a:bodyPr/>
+          <a:p/>
+        </p:txBody>
       </p:sp>
       <p:sp>
         <p:nvSpPr>
@@ -19609,6 +20197,10 @@
           </a:solidFill>
           <a:ln/>
         </p:spPr>
+        <p:txBody>
+          <a:bodyPr/>
+          <a:p/>
+        </p:txBody>
       </p:sp>
       <p:sp>
         <p:nvSpPr>
@@ -19631,6 +20223,10 @@
           </a:solidFill>
           <a:ln/>
         </p:spPr>
+        <p:txBody>
+          <a:bodyPr/>
+          <a:p/>
+        </p:txBody>
       </p:sp>
       <p:sp>
         <p:nvSpPr>
@@ -19653,6 +20249,10 @@
           </a:solidFill>
           <a:ln/>
         </p:spPr>
+        <p:txBody>
+          <a:bodyPr/>
+          <a:p/>
+        </p:txBody>
       </p:sp>
       <p:sp>
         <p:nvSpPr>
@@ -19907,6 +20507,10 @@
           </a:solidFill>
           <a:ln/>
         </p:spPr>
+        <p:txBody>
+          <a:bodyPr/>
+          <a:p/>
+        </p:txBody>
       </p:sp>
       <p:sp>
         <p:nvSpPr>
@@ -19966,6 +20570,10 @@
           </a:solidFill>
           <a:ln/>
         </p:spPr>
+        <p:txBody>
+          <a:bodyPr/>
+          <a:p/>
+        </p:txBody>
       </p:sp>
       <p:sp>
         <p:nvSpPr>
@@ -20025,6 +20633,10 @@
           </a:solidFill>
           <a:ln/>
         </p:spPr>
+        <p:txBody>
+          <a:bodyPr/>
+          <a:p/>
+        </p:txBody>
       </p:sp>
       <p:sp>
         <p:nvSpPr>
@@ -20084,6 +20696,10 @@
           </a:solidFill>
           <a:ln/>
         </p:spPr>
+        <p:txBody>
+          <a:bodyPr/>
+          <a:p/>
+        </p:txBody>
       </p:sp>
       <p:sp>
         <p:nvSpPr>
@@ -20143,6 +20759,10 @@
           </a:solidFill>
           <a:ln/>
         </p:spPr>
+        <p:txBody>
+          <a:bodyPr/>
+          <a:p/>
+        </p:txBody>
       </p:sp>
       <p:sp>
         <p:nvSpPr>
@@ -20376,6 +20996,10 @@
           </a:solidFill>
           <a:ln/>
         </p:spPr>
+        <p:txBody>
+          <a:bodyPr/>
+          <a:p/>
+        </p:txBody>
       </p:sp>
       <p:sp>
         <p:nvSpPr>
@@ -20396,6 +21020,10 @@
           </a:solidFill>
           <a:ln/>
         </p:spPr>
+        <p:txBody>
+          <a:bodyPr/>
+          <a:p/>
+        </p:txBody>
       </p:sp>
       <p:sp>
         <p:nvSpPr>
@@ -20416,6 +21044,10 @@
           </a:solidFill>
           <a:ln/>
         </p:spPr>
+        <p:txBody>
+          <a:bodyPr/>
+          <a:p/>
+        </p:txBody>
       </p:sp>
       <p:sp>
         <p:nvSpPr>
@@ -20900,6 +21532,10 @@
           </a:solidFill>
           <a:ln/>
         </p:spPr>
+        <p:txBody>
+          <a:bodyPr/>
+          <a:p/>
+        </p:txBody>
       </p:sp>
       <p:sp>
         <p:nvSpPr>
@@ -20922,6 +21558,10 @@
           </a:solidFill>
           <a:ln/>
         </p:spPr>
+        <p:txBody>
+          <a:bodyPr/>
+          <a:p/>
+        </p:txBody>
       </p:sp>
       <p:sp>
         <p:nvSpPr>
@@ -20949,6 +21589,10 @@
             <a:prstDash val="solid"/>
           </a:ln>
         </p:spPr>
+        <p:txBody>
+          <a:bodyPr/>
+          <a:p/>
+        </p:txBody>
       </p:sp>
       <p:pic>
         <p:nvPicPr>
@@ -21133,6 +21777,10 @@
           </a:solidFill>
           <a:ln/>
         </p:spPr>
+        <p:txBody>
+          <a:bodyPr/>
+          <a:p/>
+        </p:txBody>
       </p:sp>
       <p:sp>
         <p:nvSpPr>
@@ -21153,6 +21801,10 @@
           </a:solidFill>
           <a:ln/>
         </p:spPr>
+        <p:txBody>
+          <a:bodyPr/>
+          <a:p/>
+        </p:txBody>
       </p:sp>
       <p:sp>
         <p:nvSpPr>
@@ -21173,6 +21825,10 @@
           </a:solidFill>
           <a:ln/>
         </p:spPr>
+        <p:txBody>
+          <a:bodyPr/>
+          <a:p/>
+        </p:txBody>
       </p:sp>
       <p:sp>
         <p:nvSpPr>

</xml_diff>